<commit_message>
Fix malformed SVG label and rebuild editable PPTX package
</commit_message>
<xml_diff>
--- a/Taxi Upfront Pricing Precision/v2_executive_delivery/stakeholder_presentation_v2.pptx
+++ b/Taxi Upfront Pricing Precision/v2_executive_delivery/stakeholder_presentation_v2.pptx
@@ -12,6 +12,7 @@
   </p:sldIdLst>
   <p:sldSz cx="12192000" cy="6858000" type="screen16x9"/>
   <p:notesSz cx="6858000" cy="9144000"/>
+  <p:defaultTextStyle/>
 </p:presentation>
 </file>
 
@@ -27,12 +28,20 @@
       <p:grpSpPr/>
     </p:spTree>
   </p:cSld>
+  <p:clrMapOvr>
+    <a:masterClrMapping/>
+  </p:clrMapOvr>
 </p:sldLayout>
 </file>
 
 <file path=ppt/slideMasters/slideMaster1.xml><?xml version="1.0" encoding="utf-8"?>
 <p:sldMaster xmlns:a="http://schemas.openxmlformats.org/drawingml/2006/main" xmlns:r="http://schemas.openxmlformats.org/officeDocument/2006/relationships" xmlns:p="http://schemas.openxmlformats.org/presentationml/2006/main">
   <p:cSld>
+    <p:bg>
+      <p:bgRef idx="1001">
+        <a:schemeClr val="bg1"/>
+      </p:bgRef>
+    </p:bg>
     <p:spTree>
       <p:nvGrpSpPr>
         <p:cNvPr id="1" name=""/>
@@ -43,6 +52,9 @@
     </p:spTree>
   </p:cSld>
   <p:clrMap accent1="accent1" accent2="accent2" accent3="accent3" accent4="accent4" accent5="accent5" accent6="accent6" bg1="lt1" bg2="lt2" folHlink="folHlink" hlink="hlink" tx1="dk1" tx2="dk2"/>
+  <p:sldLayoutIdLst>
+    <p:sldLayoutId id="2147483649" r:id="rId1"/>
+  </p:sldLayoutIdLst>
 </p:sldMaster>
 </file>
 
@@ -87,25 +99,28 @@
           <a:p>
             <a:r>
               <a:rPr lang="en-US" sz="2000"/>
-              <a:t>Executive summary</a:t>
-            </a:r>
-          </a:p>
-          <a:p>
-            <a:r>
-              <a:rPr lang="en-US" sz="2000"/>
-              <a:t>High switch rate (&gt;20% error threshold) impacts trust</a:t>
-            </a:r>
-          </a:p>
-          <a:p>
-            <a:r>
-              <a:rPr lang="en-US" sz="2000"/>
-              <a:t>Two top actions: GPS fallback + underprediction correction</a:t>
-            </a:r>
-          </a:p>
-        </p:txBody>
-      </p:sp>
-    </p:spTree>
-  </p:cSld>
+              <a:t>• Executive summary</a:t>
+            </a:r>
+          </a:p>
+          <a:p>
+            <a:r>
+              <a:rPr lang="en-US" sz="2000"/>
+              <a:t>• High switch-rate drives fare surprise</a:t>
+            </a:r>
+          </a:p>
+          <a:p>
+            <a:r>
+              <a:rPr lang="en-US" sz="2000"/>
+              <a:t>• Top levers: GPS fallback + underprediction correction</a:t>
+            </a:r>
+          </a:p>
+        </p:txBody>
+      </p:sp>
+    </p:spTree>
+  </p:cSld>
+  <p:clrMapOvr>
+    <a:masterClrMapping/>
+  </p:clrMapOvr>
 </p:sld>
 </file>
 
@@ -150,25 +165,28 @@
           <a:p>
             <a:r>
               <a:rPr lang="en-US" sz="2000"/>
-              <a:t>Overall switch rate: 45.8%</a:t>
-            </a:r>
-          </a:p>
-          <a:p>
-            <a:r>
-              <a:rPr lang="en-US" sz="2000"/>
-              <a:t>Low GPS confidence has highest switch concentration</a:t>
-            </a:r>
-          </a:p>
-          <a:p>
-            <a:r>
-              <a:rPr lang="en-US" sz="2000"/>
-              <a:t>Destination changes and region differences are material</a:t>
-            </a:r>
-          </a:p>
-        </p:txBody>
-      </p:sp>
-    </p:spTree>
-  </p:cSld>
+              <a:t>• Switch rate is materially high</a:t>
+            </a:r>
+          </a:p>
+          <a:p>
+            <a:r>
+              <a:rPr lang="en-US" sz="2000"/>
+              <a:t>• Low GPS confidence is highest-risk segment</a:t>
+            </a:r>
+          </a:p>
+          <a:p>
+            <a:r>
+              <a:rPr lang="en-US" sz="2000"/>
+              <a:t>• Destination changes and regional variation matter</a:t>
+            </a:r>
+          </a:p>
+        </p:txBody>
+      </p:sp>
+    </p:spTree>
+  </p:cSld>
+  <p:clrMapOvr>
+    <a:masterClrMapping/>
+  </p:clrMapOvr>
 </p:sld>
 </file>
 
@@ -213,33 +231,95 @@
           <a:p>
             <a:r>
               <a:rPr lang="en-US" sz="2000"/>
-              <a:t>A/B/n design: Control vs GPS fallback vs GPS+uplift</a:t>
-            </a:r>
-          </a:p>
-          <a:p>
-            <a:r>
-              <a:rPr lang="en-US" sz="2000"/>
-              <a:t>Primary KPI: switch rate</a:t>
-            </a:r>
-          </a:p>
-          <a:p>
-            <a:r>
-              <a:rPr lang="en-US" sz="2000"/>
-              <a:t>Guardrails: conversion, cancel rate, complaints, margin</a:t>
-            </a:r>
-          </a:p>
-        </p:txBody>
-      </p:sp>
-    </p:spTree>
-  </p:cSld>
+              <a:t>• 3-arm A/B/n: control vs fallback vs fallback+uplift</a:t>
+            </a:r>
+          </a:p>
+          <a:p>
+            <a:r>
+              <a:rPr lang="en-US" sz="2000"/>
+              <a:t>• Primary KPI: switch rate</a:t>
+            </a:r>
+          </a:p>
+          <a:p>
+            <a:r>
+              <a:rPr lang="en-US" sz="2000"/>
+              <a:t>• Guardrails: conversion, cancellations, complaints, margin</a:t>
+            </a:r>
+          </a:p>
+        </p:txBody>
+      </p:sp>
+    </p:spTree>
+  </p:cSld>
+  <p:clrMapOvr>
+    <a:masterClrMapping/>
+  </p:clrMapOvr>
 </p:sld>
 </file>
 
-<file path=ppt/slides/slide4.xml><?xml version="1.0" encoding="UTF-8" standalone="yes"?>
-<p:sld xmlns:a="http://schemas.openxmlformats.org/drawingml/2006/main" xmlns:r="http://schemas.openxmlformats.org/officeDocument/2006/relationships" xmlns:p="http://schemas.openxmlformats.org/presentationml/2006/main"><p:cSld><p:spTree><p:nvGrpSpPr><p:cNvPr id="1" name=""/><p:cNvGrpSpPr/><p:nvPr/></p:nvGrpSpPr><p:grpSpPr/>
-<p:sp><p:nvSpPr><p:cNvPr id="2" name="Title"/><p:cNvSpPr/><p:nvPr/></p:nvSpPr><p:spPr/><p:txBody><a:bodyPr/><a:lstStyle/><a:p><a:r><a:rPr lang="en-US" sz="3600" b="1"/><a:t>Recommendations & Next Steps</a:t></a:r></a:p></p:txBody></p:sp>
-<p:sp><p:nvSpPr><p:cNvPr id="3" name="Body"/><p:cNvSpPr/><p:nvPr/></p:nvSpPr><p:spPr/><p:txBody><a:bodyPr/><a:lstStyle/><a:p><a:r><a:rPr lang="en-US" sz="2000"/><a:t>Pilot in high-risk segments first</a:t></a:r></a:p><a:p><a:r><a:rPr lang="en-US" sz="2000"/><a:t>Use daily monitoring + weekly recalibration</a:t></a:r></a:p><a:p><a:r><a:rPr lang="en-US" sz="2000"/><a:t>Scale if >=5pp switch-rate reduction with neutral guardrails</a:t></a:r></a:p></p:txBody></p:sp>
-</p:spTree></p:cSld></p:sld>
+<file path=ppt/slides/slide4.xml><?xml version="1.0" encoding="utf-8"?>
+<p:sld xmlns:a="http://schemas.openxmlformats.org/drawingml/2006/main" xmlns:r="http://schemas.openxmlformats.org/officeDocument/2006/relationships" xmlns:p="http://schemas.openxmlformats.org/presentationml/2006/main">
+  <p:cSld>
+    <p:spTree>
+      <p:nvGrpSpPr>
+        <p:cNvPr id="1" name=""/>
+        <p:cNvGrpSpPr/>
+        <p:nvPr/>
+      </p:nvGrpSpPr>
+      <p:grpSpPr/>
+      <p:sp>
+        <p:nvSpPr>
+          <p:cNvPr id="2" name="Title"/>
+          <p:cNvSpPr/>
+          <p:nvPr/>
+        </p:nvSpPr>
+        <p:spPr/>
+        <p:txBody>
+          <a:bodyPr/>
+          <a:lstStyle/>
+          <a:p>
+            <a:r>
+              <a:rPr lang="en-US" sz="3600" b="1"/>
+              <a:t>Recommendations</a:t>
+            </a:r>
+          </a:p>
+        </p:txBody>
+      </p:sp>
+      <p:sp>
+        <p:nvSpPr>
+          <p:cNvPr id="3" name="Body"/>
+          <p:cNvSpPr/>
+          <p:nvPr/>
+        </p:nvSpPr>
+        <p:spPr/>
+        <p:txBody>
+          <a:bodyPr/>
+          <a:lstStyle/>
+          <a:p>
+            <a:r>
+              <a:rPr lang="en-US" sz="2000"/>
+              <a:t>• Pilot high-risk segments first</a:t>
+            </a:r>
+          </a:p>
+          <a:p>
+            <a:r>
+              <a:rPr lang="en-US" sz="2000"/>
+              <a:t>• Add monitoring and weekly recalibration</a:t>
+            </a:r>
+          </a:p>
+          <a:p>
+            <a:r>
+              <a:rPr lang="en-US" sz="2000"/>
+              <a:t>• Scale rollout with explicit success/rollback criteria</a:t>
+            </a:r>
+          </a:p>
+        </p:txBody>
+      </p:sp>
+    </p:spTree>
+  </p:cSld>
+  <p:clrMapOvr>
+    <a:masterClrMapping/>
+  </p:clrMapOvr>
+</p:sld>
 </file>
 
 <file path=ppt/theme/theme1.xml><?xml version="1.0" encoding="utf-8"?>

</xml_diff>